<commit_message>
Add Teach the Teachers isiZulu draft; build its isiZulu decks
Co-Authored-By: Claude Opus 5.5 <noreply@anthropic.com>
Claude-Session: https://claude.ai/code/session_01DVvirN1GL3YvgFnXUT6gyq
</commit_message>
<xml_diff>
--- a/courses/build/teach-the-teachers/T-D2.zu.pptx
+++ b/courses/build/teach-the-teachers/T-D2.zu.pptx
@@ -5419,7 +5419,7 @@
                 </a:solidFill>
                 <a:latin typeface="Segoe Print"/>
               </a:rPr>
-              <a:t>Where does the water go?</a:t>
+              <a:t>Amanzi aya kuphi?</a:t>
             </a:r>
           </a:p>
         </p:txBody>
@@ -5496,13 +5496,13 @@
               </a:spcAft>
             </a:pPr>
             <a:r>
-              <a:rPr sz="3000" b="1">
+              <a:rPr sz="2600" b="1">
                 <a:solidFill>
                   <a:srgbClr val="1C1C1C"/>
                 </a:solidFill>
                 <a:latin typeface="Trebuchet MS"/>
               </a:rPr>
-              <a:t>•  Pour 500 ml on each bottle</a:t>
+              <a:t>•  Thelani 500 ml ebhodleleni ngalinye</a:t>
             </a:r>
           </a:p>
           <a:p>
@@ -5512,13 +5512,13 @@
               </a:spcAft>
             </a:pPr>
             <a:r>
-              <a:rPr sz="3000" b="1">
+              <a:rPr sz="2600" b="1">
                 <a:solidFill>
                   <a:srgbClr val="1C1C1C"/>
                 </a:solidFill>
                 <a:latin typeface="Trebuchet MS"/>
               </a:rPr>
-              <a:t>•  Catch and measure the runoff</a:t>
+              <a:t>•  Bambani nilinganise amanzi agelezayo</a:t>
             </a:r>
           </a:p>
           <a:p>
@@ -5528,13 +5528,13 @@
               </a:spcAft>
             </a:pPr>
             <a:r>
-              <a:rPr sz="3000" b="1">
+              <a:rPr sz="2600" b="1">
                 <a:solidFill>
                   <a:srgbClr val="1C1C1C"/>
                 </a:solidFill>
                 <a:latin typeface="Trebuchet MS"/>
               </a:rPr>
-              <a:t>•  Find three water signs</a:t>
+              <a:t>•  Tholani izimpawu ezintathu zamanzi</a:t>
             </a:r>
           </a:p>
         </p:txBody>
@@ -5784,7 +5784,7 @@
                 </a:solidFill>
                 <a:latin typeface="Segoe Print"/>
               </a:rPr>
-              <a:t>Tree talk</a:t>
+              <a:t>Ukufundisa ngaphansi kwesihlahla</a:t>
             </a:r>
           </a:p>
         </p:txBody>
@@ -5867,7 +5867,7 @@
                 </a:solidFill>
                 <a:latin typeface="Trebuchet MS"/>
               </a:rPr>
-              <a:t>•  Sun behind learners</a:t>
+              <a:t>•  Ilanga ngemuva kwabafundi</a:t>
             </a:r>
           </a:p>
           <a:p>
@@ -5883,7 +5883,7 @@
                 </a:solidFill>
                 <a:latin typeface="Trebuchet MS"/>
               </a:rPr>
-              <a:t>•  Poster at eye level</a:t>
+              <a:t>•  Iphosta ezingeni lamehlo</a:t>
             </a:r>
           </a:p>
           <a:p>
@@ -5899,7 +5899,7 @@
                 </a:solidFill>
                 <a:latin typeface="Trebuchet MS"/>
               </a:rPr>
-              <a:t>•  Stop, then talk</a:t>
+              <a:t>•  Yima, bese ukhuluma</a:t>
             </a:r>
           </a:p>
         </p:txBody>
@@ -6205,7 +6205,7 @@
                 </a:solidFill>
                 <a:latin typeface="Segoe Print"/>
               </a:rPr>
-              <a:t>Mode 1: posters only</a:t>
+              <a:t>Indlela 1: amaphosta kuphela</a:t>
             </a:r>
           </a:p>
         </p:txBody>
@@ -6288,7 +6288,7 @@
                 </a:solidFill>
                 <a:latin typeface="Trebuchet MS"/>
               </a:rPr>
-              <a:t>One lesson, three ways</a:t>
+              <a:t>Isifundo esisodwa, izindlela ezintathu</a:t>
             </a:r>
           </a:p>
           <a:p>
@@ -6304,7 +6304,7 @@
                 </a:solidFill>
                 <a:latin typeface="Trebuchet MS"/>
               </a:rPr>
-              <a:t>Today: the poster</a:t>
+              <a:t>Namuhla: iphosta</a:t>
             </a:r>
           </a:p>
         </p:txBody>
@@ -6610,7 +6610,7 @@
                 </a:solidFill>
                 <a:latin typeface="Segoe Print"/>
               </a:rPr>
-              <a:t>Teach from a poster</a:t>
+              <a:t>Fundisa ngephosta</a:t>
             </a:r>
           </a:p>
         </p:txBody>
@@ -6693,7 +6693,7 @@
                 </a:solidFill>
                 <a:latin typeface="Trebuchet MS"/>
               </a:rPr>
-              <a:t>•  Cover and reveal</a:t>
+              <a:t>•  Mboza bese uyambula</a:t>
             </a:r>
           </a:p>
           <a:p>
@@ -6709,7 +6709,7 @@
                 </a:solidFill>
                 <a:latin typeface="Trebuchet MS"/>
               </a:rPr>
-              <a:t>•  Point and ask</a:t>
+              <a:t>•  Khomba bese ubuza</a:t>
             </a:r>
           </a:p>
           <a:p>
@@ -6725,7 +6725,7 @@
                 </a:solidFill>
                 <a:latin typeface="Trebuchet MS"/>
               </a:rPr>
-              <a:t>•  Learners come to the poster</a:t>
+              <a:t>•  Abafundi beza ephosteni</a:t>
             </a:r>
           </a:p>
         </p:txBody>
@@ -7031,7 +7031,7 @@
                 </a:solidFill>
                 <a:latin typeface="Segoe Print"/>
               </a:rPr>
-              <a:t>Everyone learns</a:t>
+              <a:t>Wonke umuntu uyafunda</a:t>
             </a:r>
           </a:p>
         </p:txBody>
@@ -7108,13 +7108,13 @@
               </a:spcAft>
             </a:pPr>
             <a:r>
-              <a:rPr sz="2800" b="0">
+              <a:rPr sz="2400" b="0">
                 <a:solidFill>
                   <a:srgbClr val="1C1C1C"/>
                 </a:solidFill>
                 <a:latin typeface="Trebuchet MS"/>
               </a:rPr>
-              <a:t>•  Language time: retell it</a:t>
+              <a:t>•  Isikhathi solimi: bayaphinda bayixoxe</a:t>
             </a:r>
           </a:p>
           <a:p>
@@ -7124,13 +7124,13 @@
               </a:spcAft>
             </a:pPr>
             <a:r>
-              <a:rPr sz="2800" b="0">
+              <a:rPr sz="2400" b="0">
                 <a:solidFill>
                   <a:srgbClr val="1C1C1C"/>
                 </a:solidFill>
                 <a:latin typeface="Trebuchet MS"/>
               </a:rPr>
-              <a:t>•  A role for everyone</a:t>
+              <a:t>•  Umsebenzi womuntu wonke</a:t>
             </a:r>
           </a:p>
           <a:p>
@@ -7140,13 +7140,13 @@
               </a:spcAft>
             </a:pPr>
             <a:r>
-              <a:rPr sz="2800" b="0">
+              <a:rPr sz="2400" b="0">
                 <a:solidFill>
                   <a:srgbClr val="1C1C1C"/>
                 </a:solidFill>
                 <a:latin typeface="Trebuchet MS"/>
               </a:rPr>
-              <a:t>•  Seated jobs, picture labels</a:t>
+              <a:t>•  Imisebenzi yokuhlala phansi, amalebula ezithombe</a:t>
             </a:r>
           </a:p>
         </p:txBody>
@@ -7535,7 +7535,7 @@
                 </a:solidFill>
                 <a:latin typeface="Segoe Print"/>
               </a:rPr>
-              <a:t>Micro-teaching Round 2</a:t>
+              <a:t>Ukufundisa okuncane: Round 2</a:t>
             </a:r>
           </a:p>
         </p:txBody>
@@ -7618,7 +7618,7 @@
                 </a:solidFill>
                 <a:latin typeface="Trebuchet MS"/>
               </a:rPr>
-              <a:t>•  10 minutes, solo, posters only</a:t>
+              <a:t>•  Imizuzu 10, uwedwa, amaphosta kuphela</a:t>
             </a:r>
           </a:p>
           <a:p>
@@ -7634,7 +7634,7 @@
                 </a:solidFill>
                 <a:latin typeface="Trebuchet MS"/>
               </a:rPr>
-              <a:t>•  Observer counts talk and questions</a:t>
+              <a:t>•  Umbukeli ubala ukukhuluma nemibuzo</a:t>
             </a:r>
           </a:p>
           <a:p>
@@ -7650,7 +7650,7 @@
                 </a:solidFill>
                 <a:latin typeface="Trebuchet MS"/>
               </a:rPr>
-              <a:t>•  6 minutes feedback</a:t>
+              <a:t>•  Imizuzu 6 yempendulo</a:t>
             </a:r>
           </a:p>
         </p:txBody>
@@ -7956,7 +7956,7 @@
                 </a:solidFill>
                 <a:latin typeface="Segoe Print"/>
               </a:rPr>
-              <a:t>The talk scoreboard</a:t>
+              <a:t>Ibhodi lokukhuluma</a:t>
             </a:r>
           </a:p>
         </p:txBody>
@@ -8033,13 +8033,13 @@
               </a:spcAft>
             </a:pPr>
             <a:r>
-              <a:rPr sz="2800" b="0">
+              <a:rPr sz="2400" b="0">
                 <a:solidFill>
                   <a:srgbClr val="1C1C1C"/>
                 </a:solidFill>
                 <a:latin typeface="Trebuchet MS"/>
               </a:rPr>
-              <a:t>•  Write your own talk %</a:t>
+              <a:t>•  Bhala i-% yakho yokukhuluma</a:t>
             </a:r>
           </a:p>
           <a:p>
@@ -8049,13 +8049,13 @@
               </a:spcAft>
             </a:pPr>
             <a:r>
-              <a:rPr sz="2800" b="0">
+              <a:rPr sz="2400" b="0">
                 <a:solidFill>
                   <a:srgbClr val="1C1C1C"/>
                 </a:solidFill>
                 <a:latin typeface="Trebuchet MS"/>
               </a:rPr>
-              <a:t>•  What helped you talk less?</a:t>
+              <a:t>•  Yini ekusizile ukuthi ukhulume kancane?</a:t>
             </a:r>
           </a:p>
         </p:txBody>
@@ -8361,7 +8361,7 @@
                 </a:solidFill>
                 <a:latin typeface="Segoe Print"/>
               </a:rPr>
-              <a:t>Course craft: POPIA</a:t>
+              <a:t>Ubuciko besifundo: i-POPIA</a:t>
             </a:r>
           </a:p>
         </p:txBody>
@@ -8438,13 +8438,13 @@
               </a:spcAft>
             </a:pPr>
             <a:r>
-              <a:rPr sz="2800" b="0">
+              <a:rPr sz="2400" b="0">
                 <a:solidFill>
                   <a:srgbClr val="1C1C1C"/>
                 </a:solidFill>
                 <a:latin typeface="Trebuchet MS"/>
               </a:rPr>
-              <a:t>•  Consent before the camera</a:t>
+              <a:t>•  Imvume ngaphambi kwekhamera</a:t>
             </a:r>
           </a:p>
           <a:p>
@@ -8454,13 +8454,13 @@
               </a:spcAft>
             </a:pPr>
             <a:r>
-              <a:rPr sz="2800" b="0">
+              <a:rPr sz="2400" b="0">
                 <a:solidFill>
                   <a:srgbClr val="1C1C1C"/>
                 </a:solidFill>
                 <a:latin typeface="Trebuchet MS"/>
               </a:rPr>
-              <a:t>•  Green dot = no photos</a:t>
+              <a:t>•  Ichashaza eliluhlaza = azikho izithombe</a:t>
             </a:r>
           </a:p>
           <a:p>
@@ -8470,13 +8470,13 @@
               </a:spcAft>
             </a:pPr>
             <a:r>
-              <a:rPr sz="2800" b="0">
+              <a:rPr sz="2400" b="0">
                 <a:solidFill>
                   <a:srgbClr val="1C1C1C"/>
                 </a:solidFill>
                 <a:latin typeface="Trebuchet MS"/>
               </a:rPr>
-              <a:t>•  Share only what was agreed</a:t>
+              <a:t>•  Yabelana ngalokho okuvunyelwene ngakho kuphela</a:t>
             </a:r>
           </a:p>
         </p:txBody>
@@ -11303,7 +11303,7 @@
                 </a:solidFill>
                 <a:latin typeface="Segoe Print"/>
               </a:rPr>
-              <a:t>Model lesson under a tree</a:t>
+              <a:t>Isifundo esiyisibonelo ngaphansi kwesihlahla</a:t>
             </a:r>
           </a:p>
         </p:txBody>
@@ -11386,7 +11386,7 @@
                 </a:solidFill>
                 <a:latin typeface="Trebuchet MS"/>
               </a:rPr>
-              <a:t>Read the land and water</a:t>
+              <a:t>Funda umhlaba namanzi</a:t>
             </a:r>
           </a:p>
           <a:p>
@@ -11402,7 +11402,7 @@
                 </a:solidFill>
                 <a:latin typeface="Trebuchet MS"/>
               </a:rPr>
-              <a:t>Recorders: count question types</a:t>
+              <a:t>Ababhali: balani izinhlobo zemibuzo</a:t>
             </a:r>
           </a:p>
         </p:txBody>
@@ -11791,7 +11791,7 @@
                 </a:solidFill>
                 <a:latin typeface="Segoe Print"/>
               </a:rPr>
-              <a:t>Where is the sun?</a:t>
+              <a:t>Ilanga likuphi?</a:t>
             </a:r>
           </a:p>
         </p:txBody>
@@ -11874,7 +11874,7 @@
                 </a:solidFill>
                 <a:latin typeface="Trebuchet MS"/>
               </a:rPr>
-              <a:t>•  Window faces north</a:t>
+              <a:t>•  Iwindi libheke enyakatho</a:t>
             </a:r>
           </a:p>
           <a:p>
@@ -11890,7 +11890,7 @@
                 </a:solidFill>
                 <a:latin typeface="Trebuchet MS"/>
               </a:rPr>
-              <a:t>•  Mark winter shade with sticks</a:t>
+              <a:t>•  Makani umthunzi wasebusika ngezinduku</a:t>
             </a:r>
           </a:p>
           <a:p>
@@ -11906,7 +11906,7 @@
                 </a:solidFill>
                 <a:latin typeface="Trebuchet MS"/>
               </a:rPr>
-              <a:t>•  Which way does the shadow point?</a:t>
+              <a:t>•  Isithunzi sikhomba ngaphi?</a:t>
             </a:r>
           </a:p>
         </p:txBody>

</xml_diff>